<commit_message>
Master renumbering: one continuous sequence, pages 1-321
Corner numbers rebuilt across all 22 decks at John's word: page 1 = the
shared series title slide, Session 1 runs 2-21, each session continues
where the last left off, ending at 321. Letter-suffix interim pages
retired. slide-numbering-map.md added as the map of record; rerun the
renumber script after any future insert. Changelog v2.2.

Co-Authored-By: Claude Fable 5 <noreply@anthropic.com>
</commit_message>
<xml_diff>
--- a/_implementation-notes/evening-series/FotH Evening Session 1 Slides DRAFT v1.pptx
+++ b/_implementation-notes/evening-series/FotH Evening Session 1 Slides DRAFT v1.pptx
@@ -7813,7 +7813,7 @@
           <a:p>
             <a:pPr algn="r"/>
             <a:r>
-              <a:t>18a</a:t>
+              <a:t>19</a:t>
             </a:r>
             <a:endParaRPr sz="1000" b="1">
               <a:solidFill>
@@ -8062,7 +8062,7 @@
           <a:p>
             <a:pPr algn="r"/>
             <a:r>
-              <a:t>3</a:t>
+              <a:t>2</a:t>
             </a:r>
             <a:endParaRPr sz="1000" b="1">
               <a:solidFill>
@@ -8359,7 +8359,7 @@
           <a:p>
             <a:pPr algn="r"/>
             <a:r>
-              <a:t>19</a:t>
+              <a:t>20</a:t>
             </a:r>
             <a:endParaRPr sz="1000" b="1">
               <a:solidFill>
@@ -8804,7 +8804,7 @@
           <a:p>
             <a:pPr algn="r"/>
             <a:r>
-              <a:t>20</a:t>
+              <a:t>21</a:t>
             </a:r>
             <a:endParaRPr sz="1000" b="1">
               <a:solidFill>
@@ -8985,7 +8985,7 @@
           <a:p>
             <a:pPr algn="r"/>
             <a:r>
-              <a:t>3a</a:t>
+              <a:t>3</a:t>
             </a:r>
             <a:endParaRPr sz="1000" b="1">
               <a:solidFill>

</xml_diff>

<commit_message>
The interposed closing kept and converted (John's call): S1/S12/S14 tails on the evening clock — closing 8:24-8:26, round interposes 8:26-8:29, return/blessing 8:29-8:30 — across run sheets, leader notes, and decks; changelog v2.10; school clock now fully retired from evening artifacts
Co-Authored-By: Claude Fable 5 <noreply@anthropic.com>
</commit_message>
<xml_diff>
--- a/_implementation-notes/evening-series/FotH Evening Session 1 Slides DRAFT v1.pptx
+++ b/_implementation-notes/evening-series/FotH Evening Session 1 Slides DRAFT v1.pptx
@@ -866,7 +866,7 @@
           <a:p>
             <a:r>
               <a:rPr lang="en-US" sz="1200"/>
-              <a:t>S1 · 8:24–8:28 · LEAD: BOTH LEADERS</a:t>
+              <a:t>S1 · 8:26–8:29 · LEAD: BOTH LEADERS</a:t>
             </a:r>
           </a:p>
           <a:p>
@@ -896,7 +896,7 @@
           <a:p>
             <a:r>
               <a:rPr lang="en-US" sz="1200"/>
-              <a:t>CUES: Week 1 order: the closing container runs at 5:18 BEFORE this round; the blessing follows it at 5:27. May be dropped if the room needs something else; twice running goes to the team debrief.</a:t>
+              <a:t>CUES: Week 1 order: the closing container runs at 8:24 BEFORE this round; the blessing follows it at 8:29. May be dropped if the room needs something else; twice running goes to the team debrief.</a:t>
             </a:r>
           </a:p>
         </p:txBody>
@@ -943,7 +943,7 @@
           <a:p>
             <a:r>
               <a:rPr lang="en-US" sz="1200" dirty="0"/>
-              <a:t>S1 · 8:28–8:30 · LEAD: CONTAINER HOLDER</a:t>
+              <a:t>S1 · 8:24–8:26, blessing 8:29–8:30 · LEAD: CONTAINER HOLDER</a:t>
             </a:r>
           </a:p>
           <a:p>
@@ -973,13 +973,13 @@
           <a:p>
             <a:r>
               <a:rPr lang="en-US" sz="1200" dirty="0"/>
-              <a:t>4. Aaronic blessing at 5:27: teens face parents, hand on shoulder if comfortable; read the card together, slowly. Pause. 'Take your blessing card with you.'</a:t>
+              <a:t>4. Aaronic blessing at 8:29: teens face parents, hand on shoulder if comfortable; read the card together, slowly. Pause. 'Take your blessing card with you.'</a:t>
             </a:r>
           </a:p>
           <a:p>
             <a:r>
               <a:rPr lang="en-US" sz="1200" dirty="0"/>
-              <a:t>CUES: Week 1 order: closing 5:18, Leader Feedback Round 5:24, blessing 5:27 — the round sits inside this window.</a:t>
+              <a:t>CUES: Week 1 order: closing 8:24, Leader Feedback Round 8:26, blessing 8:29 — the round sits inside this window.</a:t>
             </a:r>
           </a:p>
         </p:txBody>

</xml_diff>

<commit_message>
v2.28 (John's word, 8 October): blessings spoken to the person on every evening deck's closing step (+ notes); the Session 5-8 lessons carried into the 22-week CCA Getting Started and the adult series — gentler Week 5, place/pattern/pull + Breakout Card, Week 6 grouping by the leaders' judgement, pairs always + timekeeper + Pair Card in Weeks 7-8, blessings spoken, day boxes where daily
Co-Authored-By: Claude Opus 5.5 <noreply@anthropic.com>
</commit_message>
<xml_diff>
--- a/_implementation-notes/evening-series/FotH Evening Session 1 Slides DRAFT v1.pptx
+++ b/_implementation-notes/evening-series/FotH Evening Session 1 Slides DRAFT v1.pptx
@@ -942,44 +942,42 @@
           <a:lstStyle/>
           <a:p>
             <a:r>
-              <a:rPr lang="en-US" sz="1200" dirty="0"/>
               <a:t>S1 · 8:24–8:26, blessing 8:29–8:30 · LEAD: CONTAINER HOLDER</a:t>
             </a:r>
           </a:p>
           <a:p>
             <a:r>
-              <a:rPr lang="en-US" sz="1200" dirty="0"/>
               <a:t>BEATS:</a:t>
             </a:r>
           </a:p>
           <a:p>
             <a:r>
-              <a:rPr lang="en-US" sz="1200" dirty="0"/>
               <a:t>1. Six-step closing (Handbook Section 5). One-word landing — any word, even 'tired'; do not push for depth today.</a:t>
             </a:r>
           </a:p>
           <a:p>
             <a:r>
-              <a:rPr lang="en-US" sz="1200" dirty="0"/>
               <a:t>2. The one practice, said aloud together: 'Father, what are You up to today, and what do You want me to notice?'</a:t>
             </a:r>
           </a:p>
           <a:p>
             <a:r>
-              <a:rPr lang="en-US" sz="1200" dirty="0"/>
               <a:t>3. Blessings: do not press in Week 1; honor any offered. Closing prayer 30 seconds, naming the Holy Spirit.</a:t>
             </a:r>
           </a:p>
           <a:p>
             <a:r>
-              <a:rPr lang="en-US" sz="1200" dirty="0"/>
               <a:t>4. Aaronic blessing at 8:29: teens face parents, hand on shoulder if comfortable; read the card together, slowly. Pause. 'Take your blessing card with you.'</a:t>
             </a:r>
           </a:p>
           <a:p>
             <a:r>
-              <a:rPr lang="en-US" sz="1200" dirty="0"/>
               <a:t>CUES: Week 1 order: closing 8:24, Leader Feedback Round 8:26, blessing 8:29 — the round sits inside this window.</a:t>
+            </a:r>
+          </a:p>
+          <a:p>
+            <a:r>
+              <a:t>BLESSINGS: eyes on the person, not the screen — nothing to read; say what is on your heart for them, specific and short.</a:t>
             </a:r>
           </a:p>
         </p:txBody>
@@ -8665,7 +8663,7 @@
                 </a:solidFill>
                 <a:latin typeface="Calibri"/>
               </a:rPr>
-              <a:t>Blessings — specific, witnessed, short</a:t>
+              <a:t>Blessings — eyes on the person, not the screen: say what is on your heart for them. Specific, witnessed, short</a:t>
             </a:r>
           </a:p>
           <a:p>

</xml_diff>

<commit_message>
v2.34 (John's word, 13 October): the walk renumbered Evening 1 to 17
Map: E1=S1, E2=S2, E3=S3-4, E4=S5, E5=S6, E6=S7-8, E7=S9-10, E8=S11,
E9=S12, E10=S13, E11=S15, E12=S16, E13=S17, E14=S18, E15=S20, E16=S21,
E17=S22 (S14 absorbed; S19's rehearsal to the planning lab). Renumbered
everything people see in the 17 evenings: slide titles, dividers, speaker-note
tags (E7 ·), run sheets, take-homes, cards, leader notes (rebuilt), sign-up
sheet, front page, handbook, evening pages, manifest. Kept: repo filenames,
URLs, corner page numbers, the spare two-session forms ("Session N"), and
"Week N" links to the school lesson plans. Sync tool now writes
"Evening N - ..." and puts spares in a "Spares - two-session forms"
subfolder; sync map updated. Front page: numbered as Sessions until
October; Evening 6 rescheduled from Oct 13, date to come. Flagged for John:
"journal Week N pages" lines and Evening 14's "Week 19" references.

Co-Authored-By: Claude Opus 5.5 <noreply@anthropic.com>
</commit_message>
<xml_diff>
--- a/_implementation-notes/evening-series/FotH Evening Session 1 Slides DRAFT v1.pptx
+++ b/_implementation-notes/evening-series/FotH Evening Session 1 Slides DRAFT v1.pptx
@@ -399,37 +399,31 @@
           <a:lstStyle/>
           <a:p>
             <a:r>
-              <a:rPr lang="en-US" sz="1200"/>
-              <a:t>S1 · 8:00–8:03 · LEAD: CONTENT PRESENTER</a:t>
-            </a:r>
-          </a:p>
-          <a:p>
-            <a:r>
-              <a:rPr lang="en-US" sz="1200"/>
+              <a:t>E1 · 8:00–8:03 · LEAD: CONTENT PRESENTER</a:t>
+            </a:r>
+          </a:p>
+          <a:p>
+            <a:r>
               <a:t>ADVANCE CUE: this slide goes up exactly at the seed's last line — 'which raises a question worth sitting with on our very first night.'</a:t>
             </a:r>
           </a:p>
           <a:p>
             <a:r>
-              <a:rPr lang="en-US" sz="1200"/>
               <a:t>BEATS:</a:t>
             </a:r>
           </a:p>
           <a:p>
             <a:r>
-              <a:rPr lang="en-US" sz="1200"/>
               <a:t>1. 'What does it mean to be saved?' — the room answers first. Parents may start; popcorn, 2–3 minutes.</a:t>
             </a:r>
           </a:p>
           <a:p>
             <a:r>
-              <a:rPr lang="en-US" sz="1200"/>
               <a:t>2. Receive every answer with a nod and a thank-you — no grading; the thief does the correcting (next slide).</a:t>
             </a:r>
           </a:p>
           <a:p>
             <a:r>
-              <a:rPr lang="en-US" sz="1200"/>
               <a:t>GUARD: an honest 'I don't know' counts; no spotlight, ever.</a:t>
             </a:r>
           </a:p>
@@ -476,31 +470,26 @@
           <a:lstStyle/>
           <a:p>
             <a:r>
-              <a:rPr lang="en-US" sz="1200"/>
-              <a:t>S1 · 8:03–8:10 · LEAD: CONTENT PRESENTER</a:t>
-            </a:r>
-          </a:p>
-          <a:p>
-            <a:r>
-              <a:rPr lang="en-US" sz="1200"/>
+              <a:t>E1 · 8:03–8:10 · LEAD: CONTENT PRESENTER</a:t>
+            </a:r>
+          </a:p>
+          <a:p>
+            <a:r>
               <a:t>BEATS:</a:t>
             </a:r>
           </a:p>
           <a:p>
             <a:r>
-              <a:rPr lang="en-US" sz="1200"/>
               <a:t>1. Read Luke 23:39–43 slowly, then show the response: no baptism, no cleaned-up life — desire aimed at Christ, and Christ's yes. Romans 10:9–10: heart and mouth.</a:t>
             </a:r>
           </a:p>
           <a:p>
             <a:r>
-              <a:rPr lang="en-US" sz="1200"/>
               <a:t>2. Land the year's working definition: saved = the desire to be connected to Christ, acted on by turning to Him.</a:t>
             </a:r>
           </a:p>
           <a:p>
             <a:r>
-              <a:rPr lang="en-US" sz="1200"/>
               <a:t>GUARD: No assurance or baptism debates today — 'the thief settles today's question; come find me.' Watch gently for the face that changes; no spotlight, ever.</a:t>
             </a:r>
           </a:p>
@@ -640,37 +629,31 @@
           <a:lstStyle/>
           <a:p>
             <a:r>
-              <a:rPr lang="en-US" sz="1200"/>
-              <a:t>S1 · 8:10–8:14 · LEAD: CONTENT PRESENTER</a:t>
-            </a:r>
-          </a:p>
-          <a:p>
-            <a:r>
-              <a:rPr lang="en-US" sz="1200"/>
+              <a:t>E1 · 8:10–8:14 · LEAD: CONTENT PRESENTER</a:t>
+            </a:r>
+          </a:p>
+          <a:p>
+            <a:r>
               <a:t>BEATS:</a:t>
             </a:r>
           </a:p>
           <a:p>
             <a:r>
-              <a:rPr lang="en-US" sz="1200"/>
               <a:t>1. Tail of the saved block. Notebooks open to the very first blank page.</a:t>
             </a:r>
           </a:p>
           <a:p>
             <a:r>
-              <a:rPr lang="en-US" sz="1200"/>
               <a:t>2. The question: if you could ask God one question and know He would answer it this year, what would you ask? The real one, not the supposed-to one. Date it.</a:t>
             </a:r>
           </a:p>
           <a:p>
             <a:r>
-              <a:rPr lang="en-US" sz="1200"/>
               <a:t>3. Two silent minutes — no music, no commentary. Companions write their own first page too, visibly.</a:t>
             </a:r>
           </a:p>
           <a:p>
             <a:r>
-              <a:rPr lang="en-US" sz="1200"/>
               <a:t>GUARD: Nobody will ever read it; the journal is never collected. Say so — the privacy is the point, and the room comes back to this page before the year ends.</a:t>
             </a:r>
           </a:p>
@@ -717,37 +700,31 @@
           <a:lstStyle/>
           <a:p>
             <a:r>
-              <a:rPr lang="en-US" sz="1200"/>
-              <a:t>S1 · 8:20–8:24 · LEAD: CONTENT PRESENTER</a:t>
-            </a:r>
-          </a:p>
-          <a:p>
-            <a:r>
-              <a:rPr lang="en-US" sz="1200"/>
+              <a:t>E1 · 8:20–8:24 · LEAD: CONTENT PRESENTER</a:t>
+            </a:r>
+          </a:p>
+          <a:p>
+            <a:r>
               <a:t>BEATS:</a:t>
             </a:r>
           </a:p>
           <a:p>
             <a:r>
-              <a:rPr lang="en-US" sz="1200"/>
               <a:t>1. Week one of two: the two questions, morning and evening. Each morning, before the phone: five minutes — 'Father, what are You up to today, and what do You want me to notice?' Then sit. The asking is the practice.</a:t>
             </a:r>
           </a:p>
           <a:p>
             <a:r>
-              <a:rPr lang="en-US" sz="1200"/>
               <a:t>2. Evening: one specific sentence in the journal — what did I notice today?</a:t>
             </a:r>
           </a:p>
           <a:p>
             <a:r>
-              <a:rPr lang="en-US" sz="1200"/>
               <a:t>3. 'Parents, you are doing this too. We'll check in next week.'</a:t>
             </a:r>
           </a:p>
           <a:p>
             <a:r>
-              <a:rPr lang="en-US" sz="1200"/>
               <a:t>CUES: The Parent Co-Companion leads this block, not you — parents need to hear from a parent that they are doing it too.</a:t>
             </a:r>
           </a:p>
@@ -794,31 +771,26 @@
           <a:lstStyle/>
           <a:p>
             <a:r>
-              <a:rPr lang="en-US" sz="1200"/>
-              <a:t>S1 · 8:20–8:24 · LEAD: CONTENT PRESENTER</a:t>
-            </a:r>
-          </a:p>
-          <a:p>
-            <a:r>
-              <a:rPr lang="en-US" sz="1200"/>
+              <a:t>E1 · 8:20–8:24 · LEAD: CONTENT PRESENTER</a:t>
+            </a:r>
+          </a:p>
+          <a:p>
+            <a:r>
               <a:t>BEATS:</a:t>
             </a:r>
           </a:p>
           <a:p>
             <a:r>
-              <a:rPr lang="en-US" sz="1200"/>
               <a:t>1. Thirty seconds, as the first-page pens settle. 'On the way into this work we ask every family five questions — some of you met them in a conversation with one of us; some of you are meeting them right now, and that is just as good a door. They're printed in your journal, right after the where-am-I-with-Jesus page. A page per question this week, or a single sentence — if you want more than the one practice.'</a:t>
             </a:r>
           </a:p>
           <a:p>
             <a:r>
-              <a:rPr lang="en-US" sz="1200"/>
               <a:t>2. Say the privacy line again, even though they know it: the journal is never collected, never read; nobody will ever ask what you wrote.</a:t>
             </a:r>
           </a:p>
           <a:p>
             <a:r>
-              <a:rPr lang="en-US" sz="1200"/>
               <a:t>GUARD: an offer, never an assignment — the week's only ask is the morning question (next slide). If the evening is running long, skip this slide without loss; the questions are in the journal either way.</a:t>
             </a:r>
           </a:p>
@@ -865,38 +837,32 @@
           <a:lstStyle/>
           <a:p>
             <a:r>
-              <a:rPr lang="en-US" sz="1200"/>
-              <a:t>S1 · 8:26–8:29 · LEAD: BOTH LEADERS</a:t>
-            </a:r>
-          </a:p>
-          <a:p>
-            <a:r>
-              <a:rPr lang="en-US" sz="1200"/>
+              <a:t>E1 · 8:26–8:29 · LEAD: BOTH LEADERS</a:t>
+            </a:r>
+          </a:p>
+          <a:p>
+            <a:r>
               <a:t>BEATS:</a:t>
             </a:r>
           </a:p>
           <a:p>
             <a:r>
-              <a:rPr lang="en-US" sz="1200"/>
               <a:t>1. Debut today. Two rounds: the container holder first, then the content presenter. Three things: what went well; what I'd do differently; what I'd tell someone teaching today's process.</a:t>
             </a:r>
           </a:p>
           <a:p>
             <a:r>
-              <a:rPr lang="en-US" sz="1200"/>
               <a:t>2. Then the room, same two questions; two or three voices is plenty.</a:t>
             </a:r>
           </a:p>
           <a:p>
             <a:r>
-              <a:rPr lang="en-US" sz="1200"/>
               <a:t>3. Receive without defending — 'thank you' is the whole response.</a:t>
             </a:r>
           </a:p>
           <a:p>
             <a:r>
-              <a:rPr lang="en-US" sz="1200"/>
-              <a:t>CUES: Week 1 order: the closing container runs at 8:24 BEFORE this round; the blessing follows it at 8:29. May be dropped if the room needs something else; twice running goes to the team debrief.</a:t>
+              <a:t>CUES: Evening 1 order: the closing container runs at 8:24 BEFORE this round; the blessing follows it at 8:29. May be dropped if the room needs something else; twice running goes to the team debrief.</a:t>
             </a:r>
           </a:p>
         </p:txBody>
@@ -942,7 +908,7 @@
           <a:lstStyle/>
           <a:p>
             <a:r>
-              <a:t>S1 · 8:24–8:26, blessing 8:29–8:30 · LEAD: CONTAINER HOLDER</a:t>
+              <a:t>E1 · 8:24–8:26, blessing 8:29–8:30 · LEAD: CONTAINER HOLDER</a:t>
             </a:r>
           </a:p>
           <a:p>
@@ -962,7 +928,7 @@
           </a:p>
           <a:p>
             <a:r>
-              <a:t>3. Blessings: do not press in Week 1; honor any offered. Closing prayer 30 seconds, naming the Holy Spirit.</a:t>
+              <a:t>3. Blessings: do not press in Evening 1; honor any offered. Closing prayer 30 seconds, naming the Holy Spirit.</a:t>
             </a:r>
           </a:p>
           <a:p>
@@ -972,7 +938,7 @@
           </a:p>
           <a:p>
             <a:r>
-              <a:t>CUES: Week 1 order: closing 8:24, Leader Feedback Round 8:26, blessing 8:29 — the round sits inside this window.</a:t>
+              <a:t>CUES: Evening 1 order: closing 8:24, Leader Feedback Round 8:26, blessing 8:29 — the round sits inside this window.</a:t>
             </a:r>
           </a:p>
           <a:p>
@@ -1023,7 +989,7 @@
           <a:lstStyle/>
           <a:p>
             <a:r>
-              <a:t>S1 · WELCOME · LEAD: CONTAINER HOLDER · GROUNDING — every session opens on this map</a:t>
+              <a:t>E1 · WELCOME · LEAD: CONTAINER HOLDER · GROUNDING — every session opens on this map</a:t>
             </a:r>
           </a:p>
           <a:p>
@@ -1033,7 +999,7 @@
           </a:p>
           <a:p>
             <a:r>
-              <a:t>1. Locate tonight on the map, plainly: Session 1 opens the whole map — all four Connects: Self, Others, God, Mission — a sequence, not four separate topics (Matt. 22:37–40).</a:t>
+              <a:t>1. Locate tonight on the map, plainly: Evening 1 opens the whole map — all four Connects: Self, Others, God, Mission — a sequence, not four separate topics (Matt. 22:37–40).</a:t>
             </a:r>
           </a:p>
           <a:p>
@@ -1094,13 +1060,11 @@
           <a:lstStyle/>
           <a:p>
             <a:r>
-              <a:rPr lang="en-US" sz="1200"/>
-              <a:t>S1 · pre-session · DIVIDER</a:t>
-            </a:r>
-          </a:p>
-          <a:p>
-            <a:r>
-              <a:rPr lang="en-US" sz="1200"/>
+              <a:t>E1 · pre-session · DIVIDER</a:t>
+            </a:r>
+          </a:p>
+          <a:p>
+            <a:r>
               <a:t>On screen through dinner and as the circle forms. Greet at the door — the slide holds the room.</a:t>
             </a:r>
           </a:p>
@@ -1147,7 +1111,7 @@
           <a:lstStyle/>
           <a:p>
             <a:r>
-              <a:t>S1 · COMMISSIONING · LEAD: CONTENT PRESENTER</a:t>
+              <a:t>E1 · COMMISSIONING · LEAD: CONTENT PRESENTER</a:t>
             </a:r>
           </a:p>
           <a:p>
@@ -1218,7 +1182,7 @@
           <a:lstStyle/>
           <a:p>
             <a:r>
-              <a:t>S1 · COMMISSIONING · LEAD: CONTENT PRESENTER</a:t>
+              <a:t>E1 · COMMISSIONING · LEAD: CONTENT PRESENTER</a:t>
             </a:r>
           </a:p>
           <a:p>
@@ -1289,37 +1253,31 @@
           <a:lstStyle/>
           <a:p>
             <a:r>
-              <a:rPr lang="en-US" sz="1200"/>
-              <a:t>S1 · 7:00–8:30 · BOTH LEADERS</a:t>
-            </a:r>
-          </a:p>
-          <a:p>
-            <a:r>
-              <a:rPr lang="en-US" sz="1200"/>
+              <a:t>E1 · 7:00–8:30 · BOTH LEADERS</a:t>
+            </a:r>
+          </a:p>
+          <a:p>
+            <a:r>
               <a:t>BEATS:</a:t>
             </a:r>
           </a:p>
           <a:p>
             <a:r>
-              <a:rPr lang="en-US" sz="1200"/>
               <a:t>1. Thirty-second walk of the night: welcome, Four Connects, first container, One True Sentence, John 10:10, the saved question, practice, close.</a:t>
             </a:r>
           </a:p>
           <a:p>
             <a:r>
-              <a:rPr lang="en-US" sz="1200"/>
-              <a:t>2. Start on time at 7:00. Whole night is one shared circle — family clusters begin Week 2.</a:t>
-            </a:r>
-          </a:p>
-          <a:p>
-            <a:r>
-              <a:rPr lang="en-US" sz="1200"/>
+              <a:t>2. Start on time at 7:00. Whole night is one shared circle — family clusters begin Evening 2.</a:t>
+            </a:r>
+          </a:p>
+          <a:p>
+            <a:r>
               <a:t>3. Timing trap: the teaching is always cuttable; the experiential blocks are not.</a:t>
             </a:r>
           </a:p>
           <a:p>
             <a:r>
-              <a:rPr lang="en-US" sz="1200"/>
               <a:t>CUES: Chairs in one circle, no table; Four Connects diagram pre-drawn on the whiteboard; leader sits in the circle, not at the head.</a:t>
             </a:r>
           </a:p>
@@ -1366,37 +1324,31 @@
           <a:lstStyle/>
           <a:p>
             <a:r>
-              <a:rPr lang="en-US" sz="1200"/>
-              <a:t>S1 · 7:00–7:08 · LEAD: CONTAINER HOLDER</a:t>
-            </a:r>
-          </a:p>
-          <a:p>
-            <a:r>
-              <a:rPr lang="en-US" sz="1200"/>
+              <a:t>E1 · 7:00–7:08 · LEAD: CONTAINER HOLDER</a:t>
+            </a:r>
+          </a:p>
+          <a:p>
+            <a:r>
               <a:t>BEATS:</a:t>
             </a:r>
           </a:p>
           <a:p>
             <a:r>
-              <a:rPr lang="en-US" sz="1200"/>
               <a:t>1. Stand at the open of the circle; wait for full silence before a word.</a:t>
             </a:r>
           </a:p>
           <a:p>
             <a:r>
-              <a:rPr lang="en-US" sz="1200"/>
               <a:t>2. Three things: today is the doorway, not the destination; no chaperones — every person is a participant; phones silenced and away (the ask is enough — no collecting, no policing).</a:t>
             </a:r>
           </a:p>
           <a:p>
             <a:r>
-              <a:rPr lang="en-US" sz="1200"/>
               <a:t>3. Around 7:05 shift to what-this-is framing: real interior work as families; not a Bible study, not youth group, not therapy — an invitation to the abundant life of John 10:10.</a:t>
             </a:r>
           </a:p>
           <a:p>
             <a:r>
-              <a:rPr lang="en-US" sz="1200"/>
               <a:t>CUES: A parent sliding into chaperone mode gets 'Today we are all participants. Let me hold the space.'</a:t>
             </a:r>
           </a:p>
@@ -1443,37 +1395,31 @@
           <a:lstStyle/>
           <a:p>
             <a:r>
-              <a:rPr lang="en-US" sz="1200"/>
-              <a:t>S1 · 7:08–7:20 · LEAD: CONTENT PRESENTER</a:t>
-            </a:r>
-          </a:p>
-          <a:p>
-            <a:r>
-              <a:rPr lang="en-US" sz="1200"/>
+              <a:t>E1 · 7:08–7:20 · LEAD: CONTENT PRESENTER</a:t>
+            </a:r>
+          </a:p>
+          <a:p>
+            <a:r>
               <a:t>BEATS:</a:t>
             </a:r>
           </a:p>
           <a:p>
             <a:r>
-              <a:rPr lang="en-US" sz="1200"/>
               <a:t>1. Stand at the whiteboard; diagram already drawn. Matthew 22 origin: two commandments, four connections.</a:t>
             </a:r>
           </a:p>
           <a:p>
             <a:r>
-              <a:rPr lang="en-US" sz="1200"/>
               <a:t>2. Walk the sequence: Self, then Others, then God, then Mission — a sequence, not four separate topics.</a:t>
             </a:r>
           </a:p>
           <a:p>
             <a:r>
-              <a:rPr lang="en-US" sz="1200"/>
               <a:t>3. Sketch the year's map, then release it: 'Don't worry about memorizing it. These twenty-two weeks will teach it to you.'</a:t>
             </a:r>
           </a:p>
           <a:p>
             <a:r>
-              <a:rPr lang="en-US" sz="1200"/>
               <a:t>GUARD: Ten minutes maximum — do not teach the whole framework today. Concrete language for teens: 'the person at your lunch table knowing what's actually going on inside you.'</a:t>
             </a:r>
           </a:p>
@@ -1520,44 +1466,37 @@
           <a:lstStyle/>
           <a:p>
             <a:r>
-              <a:rPr lang="en-US" sz="1200"/>
-              <a:t>S1 · 7:20–7:32 · LEAD: CONTAINER HOLDER</a:t>
-            </a:r>
-          </a:p>
-          <a:p>
-            <a:r>
-              <a:rPr lang="en-US" sz="1200"/>
+              <a:t>E1 · 7:20–7:32 · LEAD: CONTAINER HOLDER</a:t>
+            </a:r>
+          </a:p>
+          <a:p>
+            <a:r>
               <a:t>BEATS:</a:t>
             </a:r>
           </a:p>
           <a:p>
             <a:r>
-              <a:rPr lang="en-US" sz="1200"/>
-              <a:t>1. Most important block of Session 1 — do not rush it.</a:t>
-            </a:r>
-          </a:p>
-          <a:p>
-            <a:r>
-              <a:rPr lang="en-US" sz="1200"/>
+              <a:t>1. Most important block of Evening 1 — do not rush it.</a:t>
+            </a:r>
+          </a:p>
+          <a:p>
+            <a:r>
               <a:t>2. Name the four conditions once: Safe, Present, Clear, Intentional.</a:t>
             </a:r>
           </a:p>
           <a:p>
             <a:r>
-              <a:rPr lang="en-US" sz="1200"/>
               <a:t>3. Teach the commitment plus the honest alternative: 'I am here, and I am listening' is a full way to stand in the circle, not a lesser one. Nobody tracks who says which.</a:t>
             </a:r>
           </a:p>
           <a:p>
             <a:r>
-              <a:rPr lang="en-US" sz="1200"/>
               <a:t>4. Everyone stands; walk the eight-step opening protocol (Handbook Section 5), holding each step.</a:t>
             </a:r>
           </a:p>
           <a:p>
             <a:r>
-              <a:rPr lang="en-US" sz="1200"/>
-              <a:t>CUES: The first one-word check-in is the key moment of Week 1 — if every single person says one word, that is your first win.</a:t>
+              <a:t>CUES: The first one-word check-in is the key moment of Evening 1 — if every single person says one word, that is your first win.</a:t>
             </a:r>
           </a:p>
         </p:txBody>
@@ -1615,7 +1554,7 @@
           <a:lstStyle/>
           <a:p>
             <a:r>
-              <a:t>S1 · 7:20–7:32 · LEAD: CONTAINER HOLDER</a:t>
+              <a:t>E1 · 7:20–7:32 · LEAD: CONTAINER HOLDER</a:t>
             </a:r>
           </a:p>
           <a:p>
@@ -1691,49 +1630,41 @@
           <a:lstStyle/>
           <a:p>
             <a:r>
-              <a:rPr lang="en-US" sz="1200"/>
-              <a:t>S1 · 7:32–7:50 · LEAD: CONTAINER HOLDER</a:t>
-            </a:r>
-          </a:p>
-          <a:p>
-            <a:r>
-              <a:rPr lang="en-US" sz="1200"/>
+              <a:t>E1 · 7:32–7:50 · LEAD: CONTAINER HOLDER</a:t>
+            </a:r>
+          </a:p>
+          <a:p>
+            <a:r>
               <a:t>BEATS:</a:t>
             </a:r>
           </a:p>
           <a:p>
             <a:r>
-              <a:rPr lang="en-US" sz="1200"/>
               <a:t>1. One true sentence each on why you are here. True beats polished; 'Mom made me come' counts, and so does 'I don't know yet.'</a:t>
             </a:r>
           </a:p>
           <a:p>
             <a:r>
-              <a:rPr lang="en-US" sz="1200"/>
               <a:t>2. You go first — short and true; you set the depth and length.</a:t>
             </a:r>
           </a:p>
           <a:p>
             <a:r>
-              <a:rPr lang="en-US" sz="1200"/>
               <a:t>3. 'I pass today' is allowed; receive with 'Thanks. We're glad you're here' and move on without ceremony.</a:t>
             </a:r>
           </a:p>
           <a:p>
             <a:r>
-              <a:rPr lang="en-US" sz="1200"/>
               <a:t>CUES: The second speaker is a parent, arranged before the session — never a cold call, and never on a teen. Stem for a frozen teen: 'One reason I'm here today is ___.' Two gentle fingers for a parent giving a speech.</a:t>
             </a:r>
           </a:p>
           <a:p>
             <a:r>
-              <a:rPr lang="en-US" sz="1200"/>
               <a:t>GUARD: If something heavy lands ('I'm here because I'm drowning'): 'Thank you for trusting us with that. We will hold that.' Never process it in the circle; follow up after.</a:t>
             </a:r>
           </a:p>
           <a:p>
             <a:r>
-              <a:rPr lang="en-US" sz="1200"/>
               <a:t>SUB: The plan's example sentences are the founder's. Speak your OWN true sentence — pre-write three, pick one in the moment. Never perform someone else's.</a:t>
             </a:r>
           </a:p>
@@ -1780,37 +1711,31 @@
           <a:lstStyle/>
           <a:p>
             <a:r>
-              <a:rPr lang="en-US" sz="1200" dirty="0"/>
-              <a:t>S1 · 7:50–8:00 · LEAD: CONTENT PRESENTER</a:t>
-            </a:r>
-          </a:p>
-          <a:p>
-            <a:r>
-              <a:rPr lang="en-US" sz="1200" dirty="0"/>
+              <a:t>E1 · 7:50–8:00 · LEAD: CONTENT PRESENTER</a:t>
+            </a:r>
+          </a:p>
+          <a:p>
+            <a:r>
               <a:t>BEATS:</a:t>
             </a:r>
           </a:p>
           <a:p>
             <a:r>
-              <a:rPr lang="en-US" sz="1200" dirty="0"/>
               <a:t>1. 'Tonight's scripture. Listen for one word.' Read John 10:10 in full from the physical Bible — slowly, once. The screen holds the words; the Bible carries the reading.</a:t>
             </a:r>
           </a:p>
           <a:p>
             <a:r>
-              <a:rPr lang="en-US" sz="1200" dirty="0"/>
               <a:t>2. Abundantly — the word the year hangs on. The thief's purpose against His purpose; the more is real and it cost Him everything (John 10:11). Point to the carry-home question on the slide: not to answer tonight — to carry.</a:t>
             </a:r>
           </a:p>
           <a:p>
             <a:r>
-              <a:rPr lang="en-US" sz="1200" dirty="0"/>
               <a:t>3. Close the Bible. One beat of quiet. The seed, stated plainly (2–3 min) — full script in the plan, Block 6. The year's proclamation: do not rush it; do not decorate it.</a:t>
             </a:r>
           </a:p>
           <a:p>
             <a:r>
-              <a:rPr lang="en-US" sz="1200" dirty="0"/>
               <a:t>ADVANCE CUE: next slide exactly at the seed's last line — 'which raises a question worth sitting with on our very first night —'</a:t>
             </a:r>
           </a:p>
@@ -7962,7 +7887,7 @@
                 </a:solidFill>
                 <a:latin typeface="Calibri"/>
               </a:rPr>
-              <a:t>SESSION 1</a:t>
+              <a:t>EVENING 1</a:t>
             </a:r>
           </a:p>
           <a:p>
@@ -8938,7 +8863,7 @@
                 </a:solidFill>
                 <a:latin typeface="Calibri"/>
               </a:rPr>
-              <a:t>Session 1 opens the whole map — </a:t>
+              <a:t>Evening 1 opens the whole map — </a:t>
             </a:r>
             <a:r>
               <a:rPr sz="1800" b="1">
@@ -9122,7 +9047,7 @@
                 </a:solidFill>
                 <a:latin typeface="Cambria"/>
               </a:rPr>
-              <a:t>Session 1 — Tonight’s Road</a:t>
+              <a:t>Evening 1 — Tonight’s Road</a:t>
             </a:r>
           </a:p>
         </p:txBody>

</xml_diff>